<commit_message>
fix: corregir apellido del docente (Peñaloza)
Corregido en las fuentes (deck.js, helpers.js, generador del informe ejecutivo
y LaTeX del informe técnico) y en los documentos generados: presentación
PPTX/PDF, informe ejecutivo e informe técnico.
</commit_message>
<xml_diff>
--- a/docs/Presentación_Ejecutiva_StreamView.pptx
+++ b/docs/Presentación_Ejecutiva_StreamView.pptx
@@ -5351,7 +5351,7 @@
                 <a:ea typeface="Arial" pitchFamily="34" charset="-122"/>
                 <a:cs typeface="Arial" pitchFamily="34" charset="-120"/>
               </a:rPr>
-              <a:t>Docente: Claudio Andrés Gonzalez Penaloza  |  Duoc UC, sede Puerto Montt  |  Septiembre 2026</a:t>
+              <a:t>Docente: Claudio Andrés Gonzalez Peñaloza  |  Duoc UC, sede Puerto Montt  |  Septiembre 2026</a:t>
             </a:r>
             <a:endParaRPr lang="en-US" sz="1100" dirty="0"/>
           </a:p>
@@ -8207,7 +8207,7 @@
       </p:sp>
       <p:pic>
         <p:nvPicPr>
-          <p:cNvPr id="5" name="Image 0" descr="/home/claude/work/images/dash_presentacion.png">    </p:cNvPr>
+          <p:cNvPr id="5" name="Image 0" descr="C:\Users\molte\Downloads\visualiz\StreamView_EP1_VisualizacionDatos\images\dash_presentacion.png">    </p:cNvPr>
           <p:cNvPicPr>
             <a:picLocks noChangeAspect="1"/>
           </p:cNvPicPr>
@@ -16619,7 +16619,7 @@
       </p:sp>
       <p:pic>
         <p:nvPicPr>
-          <p:cNvPr id="5" name="Image 0" descr="/home/claude/work/images/fig02b_matriz_peliculas_presentacion.png">    </p:cNvPr>
+          <p:cNvPr id="5" name="Image 0" descr="C:\Users\molte\Downloads\visualiz\StreamView_EP1_VisualizacionDatos\images\fig02b_matriz_peliculas_presentacion.png">    </p:cNvPr>
           <p:cNvPicPr>
             <a:picLocks noChangeAspect="1"/>
           </p:cNvPicPr>

</xml_diff>